<commit_message>
Add final report and presentation files
</commit_message>
<xml_diff>
--- a/docs/COMP3011_Presentation_detailed_notes_fixed.pptx
+++ b/docs/COMP3011_Presentation_detailed_notes_fixed.pptx
@@ -4,6 +4,9 @@
   <p:sldMasterIdLst>
     <p:sldMasterId id="2147483648" r:id="rId1"/>
   </p:sldMasterIdLst>
+  <p:notesMasterIdLst>
+    <p:notesMasterId r:id="rId8"/>
+  </p:notesMasterIdLst>
   <p:sldIdLst>
     <p:sldId id="256" r:id="rId2"/>
     <p:sldId id="257" r:id="rId3"/>
@@ -12,9 +15,6 @@
     <p:sldId id="260" r:id="rId6"/>
     <p:sldId id="261" r:id="rId7"/>
   </p:sldIdLst>
-  <p:notesMasterIdLst>
-    <p:notesMasterId r:id="rId8"/>
-  </p:notesMasterIdLst>
   <p:sldSz cx="12192000" cy="6858000"/>
   <p:notesSz cx="6858000" cy="12192000"/>
   <p:defaultTextStyle>
@@ -109,6 +109,11 @@
       </a:defRPr>
     </a:lvl9pPr>
   </p:defaultTextStyle>
+  <p:extLst>
+    <p:ext uri="{EFAFB233-063F-42B5-8137-9DF3F51BA10A}">
+      <p15:sldGuideLst xmlns:p15="http://schemas.microsoft.com/office/powerpoint/2012/main"/>
+    </p:ext>
+  </p:extLst>
 </p:presentation>
 </file>
 
@@ -134,234 +139,10 @@
           <a:chExt cx="0" cy="0"/>
         </a:xfrm>
       </p:grpSpPr>
-      <p:sp>
-        <p:nvSpPr>
-          <p:cNvPr id="2" name="Header Placeholder 1"/>
-          <p:cNvSpPr>
-            <a:spLocks noGrp="1"/>
-          </p:cNvSpPr>
-          <p:nvPr>
-            <p:ph type="hdr" sz="quarter"/>
-          </p:nvPr>
-        </p:nvSpPr>
-        <p:spPr>
-          <a:xfrm>
-            <a:off x="0" y="0"/>
-            <a:ext cx="2971800" cy="458788"/>
-          </a:xfrm>
-          <a:prstGeom prst="rect">
-            <a:avLst/>
-          </a:prstGeom>
-        </p:spPr>
-        <p:txBody>
-          <a:bodyPr vert="horz" lIns="91440" tIns="45720" rIns="91440" bIns="45720" rtlCol="0"/>
-          <a:lstStyle>
-            <a:lvl1pPr algn="l">
-              <a:defRPr sz="1200"/>
-            </a:lvl1pPr>
-          </a:lstStyle>
-          <a:p>
-            <a:endParaRPr lang="en-US"/>
-          </a:p>
-        </p:txBody>
-      </p:sp>
-      <p:sp>
-        <p:nvSpPr>
-          <p:cNvPr id="3" name="Date Placeholder 2"/>
-          <p:cNvSpPr>
-            <a:spLocks noGrp="1"/>
-          </p:cNvSpPr>
-          <p:nvPr>
-            <p:ph type="dt" idx="1"/>
-          </p:nvPr>
-        </p:nvSpPr>
-        <p:spPr>
-          <a:xfrm>
-            <a:off x="3884613" y="0"/>
-            <a:ext cx="2971800" cy="458788"/>
-          </a:xfrm>
-          <a:prstGeom prst="rect">
-            <a:avLst/>
-          </a:prstGeom>
-        </p:spPr>
-        <p:txBody>
-          <a:bodyPr vert="horz" lIns="91440" tIns="45720" rIns="91440" bIns="45720" rtlCol="0"/>
-          <a:lstStyle>
-            <a:lvl1pPr algn="r">
-              <a:defRPr sz="1200"/>
-            </a:lvl1pPr>
-          </a:lstStyle>
-          <a:p>
-            <a:fld id="{5282F153-3F37-0F45-9E97-73ACFA13230C}" type="datetimeFigureOut">
-              <a:rPr lang="en-US"/>
-              <a:t>7/23/19</a:t>
-            </a:fld>
-            <a:endParaRPr lang="en-US"/>
-          </a:p>
-        </p:txBody>
-      </p:sp>
-      <p:sp>
-        <p:nvSpPr>
-          <p:cNvPr id="4" name="Slide Image Placeholder 3"/>
-          <p:cNvSpPr>
-            <a:spLocks noGrp="1" noRot="1" noChangeAspect="1"/>
-          </p:cNvSpPr>
-          <p:nvPr>
-            <p:ph type="sldImg" idx="2"/>
-          </p:nvPr>
-        </p:nvSpPr>
-        <p:spPr>
-          <a:xfrm>
-            <a:off x="685800" y="1143000"/>
-            <a:ext cx="5486400" cy="3086100"/>
-          </a:xfrm>
-          <a:prstGeom prst="rect">
-            <a:avLst/>
-          </a:prstGeom>
-          <a:noFill/>
-          <a:ln w="12700">
-            <a:solidFill>
-              <a:prstClr val="black"/>
-            </a:solidFill>
-          </a:ln>
-        </p:spPr>
-        <p:txBody>
-          <a:bodyPr vert="horz" lIns="91440" tIns="45720" rIns="91440" bIns="45720" rtlCol="0" anchor="ctr"/>
-          <a:lstStyle/>
-          <a:p>
-            <a:endParaRPr lang="en-US"/>
-          </a:p>
-        </p:txBody>
-      </p:sp>
-      <p:sp>
-        <p:nvSpPr>
-          <p:cNvPr id="5" name="Notes Placeholder 4"/>
-          <p:cNvSpPr>
-            <a:spLocks noGrp="1"/>
-          </p:cNvSpPr>
-          <p:nvPr>
-            <p:ph type="body" sz="quarter" idx="3"/>
-          </p:nvPr>
-        </p:nvSpPr>
-        <p:spPr>
-          <a:xfrm>
-            <a:off x="685800" y="4400550"/>
-            <a:ext cx="5486400" cy="3600450"/>
-          </a:xfrm>
-          <a:prstGeom prst="rect">
-            <a:avLst/>
-          </a:prstGeom>
-        </p:spPr>
-        <p:txBody>
-          <a:bodyPr vert="horz" lIns="91440" tIns="45720" rIns="91440" bIns="45720" rtlCol="0"/>
-          <a:lstStyle/>
-          <a:p>
-            <a:pPr lvl="0"/>
-            <a:r>
-              <a:rPr lang="en-US"/>
-              <a:t>Click to edit Master text styles</a:t>
-            </a:r>
-          </a:p>
-          <a:p>
-            <a:pPr lvl="1"/>
-            <a:r>
-              <a:rPr lang="en-US"/>
-              <a:t>Second level</a:t>
-            </a:r>
-          </a:p>
-          <a:p>
-            <a:pPr lvl="2"/>
-            <a:r>
-              <a:rPr lang="en-US"/>
-              <a:t>Third level</a:t>
-            </a:r>
-          </a:p>
-          <a:p>
-            <a:pPr lvl="3"/>
-            <a:r>
-              <a:rPr lang="en-US"/>
-              <a:t>Fourth level</a:t>
-            </a:r>
-          </a:p>
-          <a:p>
-            <a:pPr lvl="4"/>
-            <a:r>
-              <a:rPr lang="en-US"/>
-              <a:t>Fifth level</a:t>
-            </a:r>
-          </a:p>
-        </p:txBody>
-      </p:sp>
-      <p:sp>
-        <p:nvSpPr>
-          <p:cNvPr id="6" name="Footer Placeholder 5"/>
-          <p:cNvSpPr>
-            <a:spLocks noGrp="1"/>
-          </p:cNvSpPr>
-          <p:nvPr>
-            <p:ph type="ftr" sz="quarter" idx="4"/>
-          </p:nvPr>
-        </p:nvSpPr>
-        <p:spPr>
-          <a:xfrm>
-            <a:off x="0" y="8685213"/>
-            <a:ext cx="2971800" cy="458787"/>
-          </a:xfrm>
-          <a:prstGeom prst="rect">
-            <a:avLst/>
-          </a:prstGeom>
-        </p:spPr>
-        <p:txBody>
-          <a:bodyPr vert="horz" lIns="91440" tIns="45720" rIns="91440" bIns="45720" rtlCol="0" anchor="b"/>
-          <a:lstStyle>
-            <a:lvl1pPr algn="l">
-              <a:defRPr sz="1200"/>
-            </a:lvl1pPr>
-          </a:lstStyle>
-          <a:p>
-            <a:endParaRPr lang="en-US"/>
-          </a:p>
-        </p:txBody>
-      </p:sp>
-      <p:sp>
-        <p:nvSpPr>
-          <p:cNvPr id="7" name="Slide Number Placeholder 6"/>
-          <p:cNvSpPr>
-            <a:spLocks noGrp="1"/>
-          </p:cNvSpPr>
-          <p:nvPr>
-            <p:ph type="sldNum" sz="quarter" idx="5"/>
-          </p:nvPr>
-        </p:nvSpPr>
-        <p:spPr>
-          <a:xfrm>
-            <a:off x="3884613" y="8685213"/>
-            <a:ext cx="2971800" cy="458787"/>
-          </a:xfrm>
-          <a:prstGeom prst="rect">
-            <a:avLst/>
-          </a:prstGeom>
-        </p:spPr>
-        <p:txBody>
-          <a:bodyPr vert="horz" lIns="91440" tIns="45720" rIns="91440" bIns="45720" rtlCol="0" anchor="b"/>
-          <a:lstStyle>
-            <a:lvl1pPr algn="r">
-              <a:defRPr sz="1200"/>
-            </a:lvl1pPr>
-          </a:lstStyle>
-          <a:p>
-            <a:fld id="{CE5E9CC1-C706-0F49-92D6-E571CC5EEA8F}" type="slidenum">
-              <a:rPr lang="en-US"/>
-              <a:t>‹#›</a:t>
-            </a:fld>
-            <a:endParaRPr lang="en-US"/>
-          </a:p>
-        </p:txBody>
-      </p:sp>
     </p:spTree>
     <p:extLst>
       <p:ext uri="{BB962C8B-B14F-4D97-AF65-F5344CB8AC3E}">
-        <p14:creationId xmlns:p14="http://schemas.microsoft.com/office/powerpoint/2010/main" val="1024086991"/>
+        <p14:creationId xmlns:p14="http://schemas.microsoft.com/office/powerpoint/2010/main" val="726083448"/>
       </p:ext>
     </p:extLst>
   </p:cSld>
@@ -512,7 +293,6 @@
 - COMP3011_Coursework1_Brief__2025_2026.pdf
 - 18eca8aa-3ab9-4472-930e-cecf37e7eaa5.png (saved Postman request screenshot)</a:t>
             </a:r>
-            <a:endParaRPr lang="en-US" dirty="0"/>
           </a:p>
         </p:txBody>
       </p:sp>
@@ -602,7 +382,6 @@
 [Sources]
 - COMP3011_Coursework1_Brief__2025_2026.pdf</a:t>
             </a:r>
-            <a:endParaRPr lang="en-US" dirty="0"/>
           </a:p>
         </p:txBody>
       </p:sp>
@@ -692,7 +471,6 @@
 [Sources]
 - COMP3011_Technical_Report_appendix.docx</a:t>
             </a:r>
-            <a:endParaRPr lang="en-US" dirty="0"/>
           </a:p>
         </p:txBody>
       </p:sp>
@@ -782,7 +560,6 @@
 [Sources]
 - fa8a87f9-41a9-4bec-837d-f7dbb406f1e8.png (streak endpoint output)</a:t>
             </a:r>
-            <a:endParaRPr lang="en-US" dirty="0"/>
           </a:p>
         </p:txBody>
       </p:sp>
@@ -868,12 +645,11 @@
           <a:p>
             <a:r>
               <a:rPr lang="en-US" dirty="0"/>
-              <a:t>Here I would show that the project is not just code but a complete submission package. The screenshot on the left is the automated Django test result, where all ten tests pass. On the right I would highlight the repository evidence: the public GitHub history, the README, the API documentation PDF, and the report. This slide is important because the brief makes it clear that documentation, version control and testing matter alongside implementation.
+              <a:t>Here I would show that the project is not just code but a complete submission package. The screenshot on the left is the automated Django test result, where all 7 tests pass. On the right I would highlight the repository evidence: the public GitHub history, the README, the API documentation PDF, and the report. This slide is important because the brief makes it clear that documentation, version control and testing matter alongside implementation.
 [Sources]
 - COMP3011_Coursework1_Brief__2025_2026.pdf
 - 5b528d70-48a3-4f6f-b0eb-e518a91e3689.png (test output screenshot)</a:t>
             </a:r>
-            <a:endParaRPr lang="en-US" dirty="0"/>
           </a:p>
         </p:txBody>
       </p:sp>
@@ -964,7 +740,6 @@
 - COMP3011_Technical_Report_appendix.docx
 - COMP3011_Coursework1_Brief__2025_2026.pdf</a:t>
             </a:r>
-            <a:endParaRPr lang="en-US" dirty="0"/>
           </a:p>
         </p:txBody>
       </p:sp>
@@ -1037,6 +812,11 @@
 <file path=ppt/slideMasters/slideMaster1.xml><?xml version="1.0" encoding="utf-8"?>
 <p:sldMaster xmlns:a="http://schemas.openxmlformats.org/drawingml/2006/main" xmlns:r="http://schemas.openxmlformats.org/officeDocument/2006/relationships" xmlns:p="http://schemas.openxmlformats.org/presentationml/2006/main">
   <p:cSld>
+    <p:bg>
+      <p:bgRef idx="1001">
+        <a:schemeClr val="bg1"/>
+      </p:bgRef>
+    </p:bg>
     <p:spTree>
       <p:nvGrpSpPr>
         <p:cNvPr id="1" name=""/>
@@ -1319,6 +1099,7 @@
         <a:solidFill>
           <a:srgbClr val="FFFFFF"/>
         </a:solidFill>
+        <a:effectLst/>
       </p:bgPr>
     </p:bg>
     <p:spTree>
@@ -1361,6 +1142,13 @@
             <a:prstDash val="solid"/>
           </a:ln>
         </p:spPr>
+        <p:txBody>
+          <a:bodyPr/>
+          <a:lstStyle/>
+          <a:p>
+            <a:endParaRPr lang="en-GB"/>
+          </a:p>
+        </p:txBody>
       </p:sp>
       <p:sp>
         <p:nvSpPr>
@@ -1383,7 +1171,7 @@
           <a:bodyPr wrap="square" rtlCol="0" anchor="ctr"/>
           <a:lstStyle/>
           <a:p>
-            <a:pPr indent="0" marL="0">
+            <a:pPr marL="0" indent="0">
               <a:buNone/>
             </a:pPr>
             <a:r>
@@ -1422,7 +1210,7 @@
           <a:bodyPr wrap="square" lIns="0" tIns="0" rIns="0" bIns="0" rtlCol="0" anchor="ctr"/>
           <a:lstStyle/>
           <a:p>
-            <a:pPr indent="0" marL="0">
+            <a:pPr marL="0" indent="0">
               <a:buNone/>
             </a:pPr>
             <a:r>
@@ -1439,7 +1227,7 @@
             <a:endParaRPr lang="en-US" sz="2600" dirty="0"/>
           </a:p>
           <a:p>
-            <a:pPr indent="0" marL="0">
+            <a:pPr marL="0" indent="0">
               <a:buNone/>
             </a:pPr>
             <a:r>
@@ -1478,7 +1266,7 @@
           <a:bodyPr wrap="square" lIns="0" tIns="0" rIns="0" bIns="0" rtlCol="0" anchor="ctr"/>
           <a:lstStyle/>
           <a:p>
-            <a:pPr indent="0" marL="0">
+            <a:pPr marL="0" indent="0">
               <a:buNone/>
             </a:pPr>
             <a:r>
@@ -1495,7 +1283,7 @@
             <a:endParaRPr lang="en-US" sz="1400" dirty="0"/>
           </a:p>
           <a:p>
-            <a:pPr indent="0" marL="0">
+            <a:pPr marL="0" indent="0">
               <a:buNone/>
             </a:pPr>
             <a:r>
@@ -1539,13 +1327,20 @@
             <a:prstDash val="solid"/>
           </a:ln>
           <a:effectLst>
-            <a:outerShdw sx="100000" sy="100000" kx="0" ky="0" algn="bl" rotWithShape="0" blurRad="12700" dist="7620" dir="2700000">
+            <a:outerShdw blurRad="12700" dist="7620" dir="2700000" algn="bl" rotWithShape="0">
               <a:srgbClr val="000000">
                 <a:alpha val="12000"/>
               </a:srgbClr>
             </a:outerShdw>
           </a:effectLst>
         </p:spPr>
+        <p:txBody>
+          <a:bodyPr/>
+          <a:lstStyle/>
+          <a:p>
+            <a:endParaRPr lang="en-GB"/>
+          </a:p>
+        </p:txBody>
       </p:sp>
       <p:sp>
         <p:nvSpPr>
@@ -1568,7 +1363,7 @@
           <a:bodyPr wrap="square" lIns="0" tIns="0" rIns="0" bIns="0" rtlCol="0" anchor="ctr"/>
           <a:lstStyle/>
           <a:p>
-            <a:pPr algn="ctr" indent="0" marL="0">
+            <a:pPr marL="0" indent="0" algn="ctr">
               <a:buNone/>
             </a:pPr>
             <a:r>
@@ -1585,15 +1380,15 @@
       </p:sp>
       <p:pic>
         <p:nvPicPr>
-          <p:cNvPr id="8" name="Image 0" descr="/mnt/data/18eca8aa-3ab9-4472-930e-cecf37e7eaa5.png">    </p:cNvPr>
+          <p:cNvPr id="8" name="Image 0" descr="/mnt/data/18eca8aa-3ab9-4472-930e-cecf37e7eaa5.png"/>
           <p:cNvPicPr>
             <a:picLocks noChangeAspect="1"/>
           </p:cNvPicPr>
           <p:nvPr/>
         </p:nvPicPr>
         <p:blipFill>
-          <a:blip r:embed="rId1"/>
-          <a:srcRect l="15384" r="15384" t="0" b="0"/>
+          <a:blip r:embed="rId3"/>
+          <a:srcRect l="15384" r="15384"/>
           <a:stretch/>
         </p:blipFill>
         <p:spPr>
@@ -1627,7 +1422,7 @@
           <a:bodyPr wrap="square" rtlCol="0" anchor="ctr"/>
           <a:lstStyle/>
           <a:p>
-            <a:pPr indent="0" marL="0">
+            <a:pPr marL="0" indent="0">
               <a:buNone/>
             </a:pPr>
             <a:r>
@@ -1636,12 +1431,12 @@
                   <a:srgbClr val="1F1F1F"/>
                 </a:solidFill>
               </a:rPr>
-              <a:t>Name: [Add your name]</a:t>
+              <a:t>Name: Yamen Alazwary</a:t>
             </a:r>
             <a:endParaRPr lang="en-US" sz="1200" dirty="0"/>
           </a:p>
           <a:p>
-            <a:pPr indent="0" marL="0">
+            <a:pPr marL="0" indent="0">
               <a:buNone/>
             </a:pPr>
             <a:r>
@@ -1677,7 +1472,7 @@
           <a:bodyPr wrap="square" lIns="0" tIns="0" rIns="0" bIns="0" rtlCol="0" anchor="ctr"/>
           <a:lstStyle/>
           <a:p>
-            <a:pPr algn="r" indent="0" marL="0">
+            <a:pPr marL="0" indent="0" algn="r">
               <a:buNone/>
             </a:pPr>
             <a:r>
@@ -1708,6 +1503,7 @@
         <a:solidFill>
           <a:srgbClr val="FFFFFF"/>
         </a:solidFill>
+        <a:effectLst/>
       </p:bgPr>
     </p:bg>
     <p:spTree>
@@ -1750,6 +1546,13 @@
             <a:prstDash val="solid"/>
           </a:ln>
         </p:spPr>
+        <p:txBody>
+          <a:bodyPr/>
+          <a:lstStyle/>
+          <a:p>
+            <a:endParaRPr lang="en-GB"/>
+          </a:p>
+        </p:txBody>
       </p:sp>
       <p:sp>
         <p:nvSpPr>
@@ -1772,7 +1575,7 @@
           <a:bodyPr wrap="square" rtlCol="0" anchor="ctr"/>
           <a:lstStyle/>
           <a:p>
-            <a:pPr indent="0" marL="0">
+            <a:pPr marL="0" indent="0">
               <a:buNone/>
             </a:pPr>
             <a:r>
@@ -1811,7 +1614,7 @@
           <a:bodyPr wrap="square" lIns="0" tIns="0" rIns="0" bIns="0" rtlCol="0" anchor="ctr"/>
           <a:lstStyle/>
           <a:p>
-            <a:pPr indent="0" marL="0">
+            <a:pPr marL="0" indent="0">
               <a:buNone/>
             </a:pPr>
             <a:r>
@@ -1850,7 +1653,7 @@
           <a:bodyPr wrap="square" lIns="0" tIns="0" rIns="0" bIns="0" rtlCol="0" anchor="ctr"/>
           <a:lstStyle/>
           <a:p>
-            <a:pPr indent="0" marL="0">
+            <a:pPr marL="0" indent="0">
               <a:buNone/>
             </a:pPr>
             <a:r>
@@ -1894,6 +1697,13 @@
             <a:prstDash val="solid"/>
           </a:ln>
         </p:spPr>
+        <p:txBody>
+          <a:bodyPr/>
+          <a:lstStyle/>
+          <a:p>
+            <a:endParaRPr lang="en-GB"/>
+          </a:p>
+        </p:txBody>
       </p:sp>
       <p:sp>
         <p:nvSpPr>
@@ -1916,7 +1726,7 @@
           <a:bodyPr wrap="square" lIns="254" tIns="254" rIns="254" bIns="254" rtlCol="0" anchor="ctr"/>
           <a:lstStyle/>
           <a:p>
-            <a:pPr indent="0" marL="0">
+            <a:pPr marL="0" indent="0">
               <a:buNone/>
             </a:pPr>
             <a:r>
@@ -1928,9 +1738,6 @@
               <a:t>Problem addressed
 </a:t>
             </a:r>
-            <a:pPr indent="0" marL="0">
-              <a:buNone/>
-            </a:pPr>
             <a:r>
               <a:rPr lang="en-US" sz="1300" dirty="0">
                 <a:solidFill>
@@ -1940,9 +1747,6 @@
               <a:t>A basic habit tracker would only demonstrate simple CRUD. I wanted a design that also showed relational modelling and simple behavioural analytics.
 </a:t>
             </a:r>
-            <a:pPr indent="0" marL="0">
-              <a:buNone/>
-            </a:pPr>
             <a:r>
               <a:rPr lang="en-US" sz="1300" b="1" dirty="0">
                 <a:solidFill>
@@ -1952,9 +1756,6 @@
               <a:t>Final direction
 </a:t>
             </a:r>
-            <a:pPr indent="0" marL="0">
-              <a:buNone/>
-            </a:pPr>
             <a:r>
               <a:rPr lang="en-US" sz="1300" dirty="0">
                 <a:solidFill>
@@ -1964,9 +1765,6 @@
               <a:t>A Django API that manages habits, stores completion logs, and calculates a current streak.
 </a:t>
             </a:r>
-            <a:pPr indent="0" marL="0">
-              <a:buNone/>
-            </a:pPr>
             <a:r>
               <a:rPr lang="en-US" sz="1300" b="1" dirty="0">
                 <a:solidFill>
@@ -1976,9 +1774,6 @@
               <a:t>Why this is stronger
 </a:t>
             </a:r>
-            <a:pPr indent="0" marL="0">
-              <a:buNone/>
-            </a:pPr>
             <a:r>
               <a:rPr lang="en-US" sz="1300" dirty="0">
                 <a:solidFill>
@@ -2017,6 +1812,13 @@
             <a:prstDash val="solid"/>
           </a:ln>
         </p:spPr>
+        <p:txBody>
+          <a:bodyPr/>
+          <a:lstStyle/>
+          <a:p>
+            <a:endParaRPr lang="en-GB"/>
+          </a:p>
+        </p:txBody>
       </p:sp>
       <p:sp>
         <p:nvSpPr>
@@ -2039,7 +1841,7 @@
           <a:bodyPr wrap="square" rtlCol="0" anchor="ctr"/>
           <a:lstStyle/>
           <a:p>
-            <a:pPr algn="ctr" indent="0" marL="0">
+            <a:pPr marL="0" indent="0" algn="ctr">
               <a:buNone/>
             </a:pPr>
             <a:r>
@@ -2053,7 +1855,7 @@
             <a:endParaRPr lang="en-US" sz="1300" dirty="0"/>
           </a:p>
           <a:p>
-            <a:pPr algn="ctr" indent="0" marL="0">
+            <a:pPr marL="0" indent="0" algn="ctr">
               <a:buNone/>
             </a:pPr>
             <a:r>
@@ -2092,6 +1894,13 @@
             <a:prstDash val="solid"/>
           </a:ln>
         </p:spPr>
+        <p:txBody>
+          <a:bodyPr/>
+          <a:lstStyle/>
+          <a:p>
+            <a:endParaRPr lang="en-GB"/>
+          </a:p>
+        </p:txBody>
       </p:sp>
       <p:sp>
         <p:nvSpPr>
@@ -2119,6 +1928,13 @@
             <a:prstDash val="solid"/>
           </a:ln>
         </p:spPr>
+        <p:txBody>
+          <a:bodyPr/>
+          <a:lstStyle/>
+          <a:p>
+            <a:endParaRPr lang="en-GB"/>
+          </a:p>
+        </p:txBody>
       </p:sp>
       <p:sp>
         <p:nvSpPr>
@@ -2141,7 +1957,7 @@
           <a:bodyPr wrap="square" rtlCol="0" anchor="ctr"/>
           <a:lstStyle/>
           <a:p>
-            <a:pPr algn="ctr" indent="0" marL="0">
+            <a:pPr marL="0" indent="0" algn="ctr">
               <a:buNone/>
             </a:pPr>
             <a:r>
@@ -2155,7 +1971,7 @@
             <a:endParaRPr lang="en-US" sz="1500" dirty="0"/>
           </a:p>
           <a:p>
-            <a:pPr algn="ctr" indent="0" marL="0">
+            <a:pPr marL="0" indent="0" algn="ctr">
               <a:buNone/>
             </a:pPr>
             <a:r>
@@ -2191,7 +2007,7 @@
           <a:bodyPr wrap="square" rtlCol="0" anchor="ctr"/>
           <a:lstStyle/>
           <a:p>
-            <a:pPr algn="ctr" indent="0" marL="0">
+            <a:pPr marL="0" indent="0" algn="ctr">
               <a:buNone/>
             </a:pPr>
             <a:r>
@@ -2205,7 +2021,7 @@
             <a:endParaRPr lang="en-US" sz="1700" dirty="0"/>
           </a:p>
           <a:p>
-            <a:pPr algn="ctr" indent="0" marL="0">
+            <a:pPr marL="0" indent="0" algn="ctr">
               <a:buNone/>
             </a:pPr>
             <a:r>
@@ -2219,7 +2035,7 @@
             <a:endParaRPr lang="en-US" sz="1700" dirty="0"/>
           </a:p>
           <a:p>
-            <a:pPr algn="ctr" indent="0" marL="0">
+            <a:pPr marL="0" indent="0" algn="ctr">
               <a:buNone/>
             </a:pPr>
             <a:r>
@@ -2255,7 +2071,7 @@
           <a:bodyPr wrap="square" rtlCol="0" anchor="ctr"/>
           <a:lstStyle/>
           <a:p>
-            <a:pPr algn="ctr" indent="0" marL="0">
+            <a:pPr marL="0" indent="0" algn="ctr">
               <a:buNone/>
             </a:pPr>
             <a:r>
@@ -2291,7 +2107,7 @@
           <a:bodyPr wrap="square" lIns="0" tIns="0" rIns="0" bIns="0" rtlCol="0" anchor="ctr"/>
           <a:lstStyle/>
           <a:p>
-            <a:pPr algn="r" indent="0" marL="0">
+            <a:pPr marL="0" indent="0" algn="r">
               <a:buNone/>
             </a:pPr>
             <a:r>
@@ -2322,6 +2138,7 @@
         <a:solidFill>
           <a:srgbClr val="FFFFFF"/>
         </a:solidFill>
+        <a:effectLst/>
       </p:bgPr>
     </p:bg>
     <p:spTree>
@@ -2364,6 +2181,13 @@
             <a:prstDash val="solid"/>
           </a:ln>
         </p:spPr>
+        <p:txBody>
+          <a:bodyPr/>
+          <a:lstStyle/>
+          <a:p>
+            <a:endParaRPr lang="en-GB"/>
+          </a:p>
+        </p:txBody>
       </p:sp>
       <p:sp>
         <p:nvSpPr>
@@ -2386,7 +2210,7 @@
           <a:bodyPr wrap="square" rtlCol="0" anchor="ctr"/>
           <a:lstStyle/>
           <a:p>
-            <a:pPr indent="0" marL="0">
+            <a:pPr marL="0" indent="0">
               <a:buNone/>
             </a:pPr>
             <a:r>
@@ -2425,7 +2249,7 @@
           <a:bodyPr wrap="square" lIns="0" tIns="0" rIns="0" bIns="0" rtlCol="0" anchor="ctr"/>
           <a:lstStyle/>
           <a:p>
-            <a:pPr indent="0" marL="0">
+            <a:pPr marL="0" indent="0">
               <a:buNone/>
             </a:pPr>
             <a:r>
@@ -2464,7 +2288,7 @@
           <a:bodyPr wrap="square" lIns="0" tIns="0" rIns="0" bIns="0" rtlCol="0" anchor="ctr"/>
           <a:lstStyle/>
           <a:p>
-            <a:pPr indent="0" marL="0">
+            <a:pPr marL="0" indent="0">
               <a:buNone/>
             </a:pPr>
             <a:r>
@@ -2506,6 +2330,13 @@
             <a:tailEnd type="triangle"/>
           </a:ln>
         </p:spPr>
+        <p:txBody>
+          <a:bodyPr/>
+          <a:lstStyle/>
+          <a:p>
+            <a:endParaRPr lang="en-GB"/>
+          </a:p>
+        </p:txBody>
       </p:sp>
       <p:sp>
         <p:nvSpPr>
@@ -2533,6 +2364,13 @@
             <a:prstDash val="solid"/>
           </a:ln>
         </p:spPr>
+        <p:txBody>
+          <a:bodyPr/>
+          <a:lstStyle/>
+          <a:p>
+            <a:endParaRPr lang="en-GB"/>
+          </a:p>
+        </p:txBody>
       </p:sp>
       <p:sp>
         <p:nvSpPr>
@@ -2555,7 +2393,7 @@
           <a:bodyPr wrap="square" rtlCol="0" anchor="ctr"/>
           <a:lstStyle/>
           <a:p>
-            <a:pPr indent="0" marL="0">
+            <a:pPr marL="0" indent="0">
               <a:buNone/>
             </a:pPr>
             <a:r>
@@ -2591,7 +2429,7 @@
           <a:bodyPr wrap="square" rtlCol="0" anchor="ctr"/>
           <a:lstStyle/>
           <a:p>
-            <a:pPr indent="0" marL="0">
+            <a:pPr marL="0" indent="0">
               <a:buNone/>
             </a:pPr>
             <a:r>
@@ -2605,7 +2443,7 @@
             <a:endParaRPr lang="en-US" sz="1600" dirty="0"/>
           </a:p>
           <a:p>
-            <a:pPr indent="0" marL="0">
+            <a:pPr marL="0" indent="0">
               <a:buNone/>
             </a:pPr>
             <a:r>
@@ -2619,7 +2457,7 @@
             <a:endParaRPr lang="en-US" sz="1600" dirty="0"/>
           </a:p>
           <a:p>
-            <a:pPr indent="0" marL="0">
+            <a:pPr marL="0" indent="0">
               <a:buNone/>
             </a:pPr>
             <a:r>
@@ -2633,7 +2471,7 @@
             <a:endParaRPr lang="en-US" sz="1600" dirty="0"/>
           </a:p>
           <a:p>
-            <a:pPr indent="0" marL="0">
+            <a:pPr marL="0" indent="0">
               <a:buNone/>
             </a:pPr>
             <a:r>
@@ -2647,7 +2485,7 @@
             <a:endParaRPr lang="en-US" sz="1600" dirty="0"/>
           </a:p>
           <a:p>
-            <a:pPr indent="0" marL="0">
+            <a:pPr marL="0" indent="0">
               <a:buNone/>
             </a:pPr>
             <a:r>
@@ -2683,7 +2521,7 @@
           <a:bodyPr wrap="square" rtlCol="0" anchor="ctr"/>
           <a:lstStyle/>
           <a:p>
-            <a:pPr indent="0" marL="0">
+            <a:pPr marL="0" indent="0">
               <a:buNone/>
             </a:pPr>
             <a:r>
@@ -2724,6 +2562,13 @@
             <a:prstDash val="solid"/>
           </a:ln>
         </p:spPr>
+        <p:txBody>
+          <a:bodyPr/>
+          <a:lstStyle/>
+          <a:p>
+            <a:endParaRPr lang="en-GB"/>
+          </a:p>
+        </p:txBody>
       </p:sp>
       <p:sp>
         <p:nvSpPr>
@@ -2746,7 +2591,7 @@
           <a:bodyPr wrap="square" rtlCol="0" anchor="ctr"/>
           <a:lstStyle/>
           <a:p>
-            <a:pPr indent="0" marL="0">
+            <a:pPr marL="0" indent="0">
               <a:buNone/>
             </a:pPr>
             <a:r>
@@ -2782,7 +2627,7 @@
           <a:bodyPr wrap="square" rtlCol="0" anchor="ctr"/>
           <a:lstStyle/>
           <a:p>
-            <a:pPr indent="0" marL="0">
+            <a:pPr marL="0" indent="0">
               <a:buNone/>
             </a:pPr>
             <a:r>
@@ -2796,7 +2641,7 @@
             <a:endParaRPr lang="en-US" sz="1600" dirty="0"/>
           </a:p>
           <a:p>
-            <a:pPr indent="0" marL="0">
+            <a:pPr marL="0" indent="0">
               <a:buNone/>
             </a:pPr>
             <a:r>
@@ -2810,7 +2655,7 @@
             <a:endParaRPr lang="en-US" sz="1600" dirty="0"/>
           </a:p>
           <a:p>
-            <a:pPr indent="0" marL="0">
+            <a:pPr marL="0" indent="0">
               <a:buNone/>
             </a:pPr>
             <a:r>
@@ -2824,7 +2669,7 @@
             <a:endParaRPr lang="en-US" sz="1600" dirty="0"/>
           </a:p>
           <a:p>
-            <a:pPr indent="0" marL="0">
+            <a:pPr marL="0" indent="0">
               <a:buNone/>
             </a:pPr>
             <a:r>
@@ -2838,7 +2683,7 @@
             <a:endParaRPr lang="en-US" sz="1600" dirty="0"/>
           </a:p>
           <a:p>
-            <a:pPr indent="0" marL="0">
+            <a:pPr marL="0" indent="0">
               <a:buNone/>
             </a:pPr>
             <a:r>
@@ -2874,7 +2719,7 @@
           <a:bodyPr wrap="square" rtlCol="0" anchor="ctr"/>
           <a:lstStyle/>
           <a:p>
-            <a:pPr indent="0" marL="0">
+            <a:pPr marL="0" indent="0">
               <a:buNone/>
             </a:pPr>
             <a:r>
@@ -2910,7 +2755,7 @@
           <a:bodyPr wrap="square" rtlCol="0" anchor="ctr"/>
           <a:lstStyle/>
           <a:p>
-            <a:pPr algn="ctr" indent="0" marL="0">
+            <a:pPr marL="0" indent="0" algn="ctr">
               <a:buNone/>
             </a:pPr>
             <a:r>
@@ -2946,7 +2791,7 @@
           <a:bodyPr wrap="square" lIns="0" tIns="0" rIns="0" bIns="0" rtlCol="0" anchor="ctr"/>
           <a:lstStyle/>
           <a:p>
-            <a:pPr algn="r" indent="0" marL="0">
+            <a:pPr marL="0" indent="0" algn="r">
               <a:buNone/>
             </a:pPr>
             <a:r>
@@ -2977,6 +2822,7 @@
         <a:solidFill>
           <a:srgbClr val="FFFFFF"/>
         </a:solidFill>
+        <a:effectLst/>
       </p:bgPr>
     </p:bg>
     <p:spTree>
@@ -3019,6 +2865,13 @@
             <a:prstDash val="solid"/>
           </a:ln>
         </p:spPr>
+        <p:txBody>
+          <a:bodyPr/>
+          <a:lstStyle/>
+          <a:p>
+            <a:endParaRPr lang="en-GB"/>
+          </a:p>
+        </p:txBody>
       </p:sp>
       <p:sp>
         <p:nvSpPr>
@@ -3041,7 +2894,7 @@
           <a:bodyPr wrap="square" rtlCol="0" anchor="ctr"/>
           <a:lstStyle/>
           <a:p>
-            <a:pPr indent="0" marL="0">
+            <a:pPr marL="0" indent="0">
               <a:buNone/>
             </a:pPr>
             <a:r>
@@ -3080,7 +2933,7 @@
           <a:bodyPr wrap="square" lIns="0" tIns="0" rIns="0" bIns="0" rtlCol="0" anchor="ctr"/>
           <a:lstStyle/>
           <a:p>
-            <a:pPr indent="0" marL="0">
+            <a:pPr marL="0" indent="0">
               <a:buNone/>
             </a:pPr>
             <a:r>
@@ -3119,7 +2972,7 @@
           <a:bodyPr wrap="square" lIns="0" tIns="0" rIns="0" bIns="0" rtlCol="0" anchor="ctr"/>
           <a:lstStyle/>
           <a:p>
-            <a:pPr indent="0" marL="0">
+            <a:pPr marL="0" indent="0">
               <a:buNone/>
             </a:pPr>
             <a:r>
@@ -3163,6 +3016,13 @@
             <a:prstDash val="solid"/>
           </a:ln>
         </p:spPr>
+        <p:txBody>
+          <a:bodyPr/>
+          <a:lstStyle/>
+          <a:p>
+            <a:endParaRPr lang="en-GB"/>
+          </a:p>
+        </p:txBody>
       </p:sp>
       <p:sp>
         <p:nvSpPr>
@@ -3185,7 +3045,7 @@
           <a:bodyPr wrap="square" rtlCol="0" anchor="ctr"/>
           <a:lstStyle/>
           <a:p>
-            <a:pPr indent="0" marL="0">
+            <a:pPr marL="0" indent="0">
               <a:buNone/>
             </a:pPr>
             <a:r>
@@ -3221,7 +3081,7 @@
           <a:bodyPr wrap="square" rtlCol="0" anchor="ctr"/>
           <a:lstStyle/>
           <a:p>
-            <a:pPr indent="0" marL="0">
+            <a:pPr marL="0" indent="0">
               <a:buNone/>
             </a:pPr>
             <a:r>
@@ -3238,7 +3098,7 @@
             <a:endParaRPr lang="en-US" sz="1600" dirty="0"/>
           </a:p>
           <a:p>
-            <a:pPr indent="0" marL="0">
+            <a:pPr marL="0" indent="0">
               <a:buNone/>
             </a:pPr>
             <a:r>
@@ -3255,7 +3115,7 @@
             <a:endParaRPr lang="en-US" sz="1600" dirty="0"/>
           </a:p>
           <a:p>
-            <a:pPr indent="0" marL="0">
+            <a:pPr marL="0" indent="0">
               <a:buNone/>
             </a:pPr>
             <a:r>
@@ -3272,7 +3132,7 @@
             <a:endParaRPr lang="en-US" sz="1600" dirty="0"/>
           </a:p>
           <a:p>
-            <a:pPr indent="0" marL="0">
+            <a:pPr marL="0" indent="0">
               <a:buNone/>
             </a:pPr>
             <a:r>
@@ -3289,7 +3149,7 @@
             <a:endParaRPr lang="en-US" sz="1600" dirty="0"/>
           </a:p>
           <a:p>
-            <a:pPr indent="0" marL="0">
+            <a:pPr marL="0" indent="0">
               <a:buNone/>
             </a:pPr>
             <a:r>
@@ -3306,7 +3166,7 @@
             <a:endParaRPr lang="en-US" sz="1600" dirty="0"/>
           </a:p>
           <a:p>
-            <a:pPr indent="0" marL="0">
+            <a:pPr marL="0" indent="0">
               <a:buNone/>
             </a:pPr>
             <a:r>
@@ -3345,7 +3205,7 @@
           <a:bodyPr wrap="square" rtlCol="0" anchor="ctr"/>
           <a:lstStyle/>
           <a:p>
-            <a:pPr indent="0" marL="0">
+            <a:pPr marL="0" indent="0">
               <a:buNone/>
             </a:pPr>
             <a:r>
@@ -3386,6 +3246,13 @@
             <a:prstDash val="solid"/>
           </a:ln>
         </p:spPr>
+        <p:txBody>
+          <a:bodyPr/>
+          <a:lstStyle/>
+          <a:p>
+            <a:endParaRPr lang="en-GB"/>
+          </a:p>
+        </p:txBody>
       </p:sp>
       <p:sp>
         <p:nvSpPr>
@@ -3408,7 +3275,7 @@
           <a:bodyPr wrap="square" rtlCol="0" anchor="ctr"/>
           <a:lstStyle/>
           <a:p>
-            <a:pPr indent="0" marL="0">
+            <a:pPr marL="0" indent="0">
               <a:buNone/>
             </a:pPr>
             <a:r>
@@ -3444,7 +3311,7 @@
           <a:bodyPr wrap="square" rtlCol="0" anchor="ctr"/>
           <a:lstStyle/>
           <a:p>
-            <a:pPr indent="0" marL="0">
+            <a:pPr marL="0" indent="0">
               <a:buNone/>
             </a:pPr>
             <a:r>
@@ -3461,7 +3328,7 @@
             <a:endParaRPr lang="en-US" sz="1600" dirty="0"/>
           </a:p>
           <a:p>
-            <a:pPr indent="0" marL="0">
+            <a:pPr marL="0" indent="0">
               <a:buNone/>
             </a:pPr>
             <a:r>
@@ -3478,7 +3345,7 @@
             <a:endParaRPr lang="en-US" sz="1600" dirty="0"/>
           </a:p>
           <a:p>
-            <a:pPr indent="0" marL="0">
+            <a:pPr marL="0" indent="0">
               <a:buNone/>
             </a:pPr>
             <a:r>
@@ -3498,14 +3365,14 @@
       </p:sp>
       <p:pic>
         <p:nvPicPr>
-          <p:cNvPr id="13" name="Image 0" descr="/mnt/data/fa8a87f9-41a9-4bec-837d-f7dbb406f1e8.png">    </p:cNvPr>
+          <p:cNvPr id="13" name="Image 0" descr="/mnt/data/fa8a87f9-41a9-4bec-837d-f7dbb406f1e8.png"/>
           <p:cNvPicPr>
             <a:picLocks noChangeAspect="1"/>
           </p:cNvPicPr>
           <p:nvPr/>
         </p:nvPicPr>
         <p:blipFill>
-          <a:blip r:embed="rId1"/>
+          <a:blip r:embed="rId3"/>
           <a:stretch>
             <a:fillRect/>
           </a:stretch>
@@ -3541,7 +3408,7 @@
           <a:bodyPr wrap="square" lIns="0" tIns="0" rIns="0" bIns="0" rtlCol="0" anchor="ctr"/>
           <a:lstStyle/>
           <a:p>
-            <a:pPr indent="0" marL="0">
+            <a:pPr marL="0" indent="0">
               <a:buNone/>
             </a:pPr>
             <a:r>
@@ -3577,7 +3444,7 @@
           <a:bodyPr wrap="square" lIns="0" tIns="0" rIns="0" bIns="0" rtlCol="0" anchor="ctr"/>
           <a:lstStyle/>
           <a:p>
-            <a:pPr algn="r" indent="0" marL="0">
+            <a:pPr marL="0" indent="0" algn="r">
               <a:buNone/>
             </a:pPr>
             <a:r>
@@ -3608,6 +3475,7 @@
         <a:solidFill>
           <a:srgbClr val="FFFFFF"/>
         </a:solidFill>
+        <a:effectLst/>
       </p:bgPr>
     </p:bg>
     <p:spTree>
@@ -3650,6 +3518,13 @@
             <a:prstDash val="solid"/>
           </a:ln>
         </p:spPr>
+        <p:txBody>
+          <a:bodyPr/>
+          <a:lstStyle/>
+          <a:p>
+            <a:endParaRPr lang="en-GB"/>
+          </a:p>
+        </p:txBody>
       </p:sp>
       <p:sp>
         <p:nvSpPr>
@@ -3672,7 +3547,7 @@
           <a:bodyPr wrap="square" rtlCol="0" anchor="ctr"/>
           <a:lstStyle/>
           <a:p>
-            <a:pPr indent="0" marL="0">
+            <a:pPr marL="0" indent="0">
               <a:buNone/>
             </a:pPr>
             <a:r>
@@ -3711,7 +3586,7 @@
           <a:bodyPr wrap="square" lIns="0" tIns="0" rIns="0" bIns="0" rtlCol="0" anchor="ctr"/>
           <a:lstStyle/>
           <a:p>
-            <a:pPr indent="0" marL="0">
+            <a:pPr marL="0" indent="0">
               <a:buNone/>
             </a:pPr>
             <a:r>
@@ -3750,7 +3625,7 @@
           <a:bodyPr wrap="square" lIns="0" tIns="0" rIns="0" bIns="0" rtlCol="0" anchor="ctr"/>
           <a:lstStyle/>
           <a:p>
-            <a:pPr indent="0" marL="0">
+            <a:pPr marL="0" indent="0">
               <a:buNone/>
             </a:pPr>
             <a:r>
@@ -3770,14 +3645,14 @@
       </p:sp>
       <p:pic>
         <p:nvPicPr>
-          <p:cNvPr id="6" name="Image 0" descr="/mnt/data/5b528d70-48a3-4f6f-b0eb-e518a91e3689.png">    </p:cNvPr>
+          <p:cNvPr id="6" name="Image 0" descr="/mnt/data/5b528d70-48a3-4f6f-b0eb-e518a91e3689.png"/>
           <p:cNvPicPr>
             <a:picLocks noChangeAspect="1"/>
           </p:cNvPicPr>
           <p:nvPr/>
         </p:nvPicPr>
         <p:blipFill>
-          <a:blip r:embed="rId1"/>
+          <a:blip r:embed="rId3"/>
           <a:stretch>
             <a:fillRect/>
           </a:stretch>
@@ -3818,6 +3693,13 @@
             <a:prstDash val="solid"/>
           </a:ln>
         </p:spPr>
+        <p:txBody>
+          <a:bodyPr/>
+          <a:lstStyle/>
+          <a:p>
+            <a:endParaRPr lang="en-GB"/>
+          </a:p>
+        </p:txBody>
       </p:sp>
       <p:sp>
         <p:nvSpPr>
@@ -3840,7 +3722,7 @@
           <a:bodyPr wrap="square" rtlCol="0" anchor="ctr"/>
           <a:lstStyle/>
           <a:p>
-            <a:pPr indent="0" marL="0">
+            <a:pPr marL="0" indent="0">
               <a:buNone/>
             </a:pPr>
             <a:r>
@@ -3876,7 +3758,7 @@
           <a:bodyPr wrap="square" rtlCol="0" anchor="ctr"/>
           <a:lstStyle/>
           <a:p>
-            <a:pPr indent="0" marL="0">
+            <a:pPr marL="0" indent="0">
               <a:buNone/>
             </a:pPr>
             <a:r>
@@ -3890,7 +3772,7 @@
             <a:endParaRPr lang="en-US" sz="1600" dirty="0"/>
           </a:p>
           <a:p>
-            <a:pPr indent="0" marL="0">
+            <a:pPr marL="0" indent="0">
               <a:buNone/>
             </a:pPr>
             <a:r>
@@ -3904,7 +3786,7 @@
             <a:endParaRPr lang="en-US" sz="1600" dirty="0"/>
           </a:p>
           <a:p>
-            <a:pPr indent="0" marL="0">
+            <a:pPr marL="0" indent="0">
               <a:buNone/>
             </a:pPr>
             <a:r>
@@ -3918,7 +3800,7 @@
             <a:endParaRPr lang="en-US" sz="1600" dirty="0"/>
           </a:p>
           <a:p>
-            <a:pPr indent="0" marL="0">
+            <a:pPr marL="0" indent="0">
               <a:buNone/>
             </a:pPr>
             <a:r>
@@ -3932,7 +3814,7 @@
             <a:endParaRPr lang="en-US" sz="1600" dirty="0"/>
           </a:p>
           <a:p>
-            <a:pPr indent="0" marL="0">
+            <a:pPr marL="0" indent="0">
               <a:buNone/>
             </a:pPr>
             <a:r>
@@ -3946,7 +3828,7 @@
             <a:endParaRPr lang="en-US" sz="1600" dirty="0"/>
           </a:p>
           <a:p>
-            <a:pPr indent="0" marL="0">
+            <a:pPr marL="0" indent="0">
               <a:buNone/>
             </a:pPr>
             <a:r>
@@ -3982,7 +3864,7 @@
           <a:bodyPr wrap="square" rtlCol="0" anchor="ctr"/>
           <a:lstStyle/>
           <a:p>
-            <a:pPr indent="0" marL="0">
+            <a:pPr marL="0" indent="0">
               <a:buNone/>
             </a:pPr>
             <a:r>
@@ -4018,7 +3900,7 @@
           <a:bodyPr wrap="square" rtlCol="0" anchor="ctr"/>
           <a:lstStyle/>
           <a:p>
-            <a:pPr indent="0" marL="0">
+            <a:pPr marL="0" indent="0">
               <a:buNone/>
             </a:pPr>
             <a:r>
@@ -4054,7 +3936,7 @@
           <a:bodyPr wrap="square" rtlCol="0" anchor="ctr"/>
           <a:lstStyle/>
           <a:p>
-            <a:pPr indent="0" marL="0">
+            <a:pPr marL="0" indent="0">
               <a:buNone/>
             </a:pPr>
             <a:r>
@@ -4090,7 +3972,7 @@
           <a:bodyPr wrap="square" lIns="0" tIns="0" rIns="0" bIns="0" rtlCol="0" anchor="ctr"/>
           <a:lstStyle/>
           <a:p>
-            <a:pPr algn="r" indent="0" marL="0">
+            <a:pPr marL="0" indent="0" algn="r">
               <a:buNone/>
             </a:pPr>
             <a:r>
@@ -4121,6 +4003,7 @@
         <a:solidFill>
           <a:srgbClr val="FFFFFF"/>
         </a:solidFill>
+        <a:effectLst/>
       </p:bgPr>
     </p:bg>
     <p:spTree>
@@ -4163,6 +4046,13 @@
             <a:prstDash val="solid"/>
           </a:ln>
         </p:spPr>
+        <p:txBody>
+          <a:bodyPr/>
+          <a:lstStyle/>
+          <a:p>
+            <a:endParaRPr lang="en-GB"/>
+          </a:p>
+        </p:txBody>
       </p:sp>
       <p:sp>
         <p:nvSpPr>
@@ -4185,7 +4075,7 @@
           <a:bodyPr wrap="square" rtlCol="0" anchor="ctr"/>
           <a:lstStyle/>
           <a:p>
-            <a:pPr indent="0" marL="0">
+            <a:pPr marL="0" indent="0">
               <a:buNone/>
             </a:pPr>
             <a:r>
@@ -4224,7 +4114,7 @@
           <a:bodyPr wrap="square" lIns="0" tIns="0" rIns="0" bIns="0" rtlCol="0" anchor="ctr"/>
           <a:lstStyle/>
           <a:p>
-            <a:pPr indent="0" marL="0">
+            <a:pPr marL="0" indent="0">
               <a:buNone/>
             </a:pPr>
             <a:r>
@@ -4263,7 +4153,7 @@
           <a:bodyPr wrap="square" lIns="0" tIns="0" rIns="0" bIns="0" rtlCol="0" anchor="ctr"/>
           <a:lstStyle/>
           <a:p>
-            <a:pPr indent="0" marL="0">
+            <a:pPr marL="0" indent="0">
               <a:buNone/>
             </a:pPr>
             <a:r>
@@ -4307,6 +4197,13 @@
             <a:prstDash val="solid"/>
           </a:ln>
         </p:spPr>
+        <p:txBody>
+          <a:bodyPr/>
+          <a:lstStyle/>
+          <a:p>
+            <a:endParaRPr lang="en-GB"/>
+          </a:p>
+        </p:txBody>
       </p:sp>
       <p:sp>
         <p:nvSpPr>
@@ -4329,7 +4226,7 @@
           <a:bodyPr wrap="square" rtlCol="0" anchor="ctr"/>
           <a:lstStyle/>
           <a:p>
-            <a:pPr indent="0" marL="0">
+            <a:pPr marL="0" indent="0">
               <a:buNone/>
             </a:pPr>
             <a:r>
@@ -4365,7 +4262,7 @@
           <a:bodyPr wrap="square" rtlCol="0" anchor="ctr"/>
           <a:lstStyle/>
           <a:p>
-            <a:pPr indent="0" marL="0">
+            <a:pPr marL="0" indent="0">
               <a:buNone/>
             </a:pPr>
             <a:r>
@@ -4379,7 +4276,7 @@
             <a:endParaRPr lang="en-US" sz="1500" dirty="0"/>
           </a:p>
           <a:p>
-            <a:pPr indent="0" marL="0">
+            <a:pPr marL="0" indent="0">
               <a:buNone/>
             </a:pPr>
             <a:r>
@@ -4393,7 +4290,7 @@
             <a:endParaRPr lang="en-US" sz="1500" dirty="0"/>
           </a:p>
           <a:p>
-            <a:pPr indent="0" marL="0">
+            <a:pPr marL="0" indent="0">
               <a:buNone/>
             </a:pPr>
             <a:r>
@@ -4407,7 +4304,7 @@
             <a:endParaRPr lang="en-US" sz="1500" dirty="0"/>
           </a:p>
           <a:p>
-            <a:pPr indent="0" marL="0">
+            <a:pPr marL="0" indent="0">
               <a:buNone/>
             </a:pPr>
             <a:r>
@@ -4448,6 +4345,13 @@
             <a:prstDash val="solid"/>
           </a:ln>
         </p:spPr>
+        <p:txBody>
+          <a:bodyPr/>
+          <a:lstStyle/>
+          <a:p>
+            <a:endParaRPr lang="en-GB"/>
+          </a:p>
+        </p:txBody>
       </p:sp>
       <p:sp>
         <p:nvSpPr>
@@ -4470,7 +4374,7 @@
           <a:bodyPr wrap="square" rtlCol="0" anchor="ctr"/>
           <a:lstStyle/>
           <a:p>
-            <a:pPr indent="0" marL="0">
+            <a:pPr marL="0" indent="0">
               <a:buNone/>
             </a:pPr>
             <a:r>
@@ -4506,7 +4410,7 @@
           <a:bodyPr wrap="square" rtlCol="0" anchor="ctr"/>
           <a:lstStyle/>
           <a:p>
-            <a:pPr indent="0" marL="0">
+            <a:pPr marL="0" indent="0">
               <a:buNone/>
             </a:pPr>
             <a:r>
@@ -4520,7 +4424,7 @@
             <a:endParaRPr lang="en-US" sz="1500" dirty="0"/>
           </a:p>
           <a:p>
-            <a:pPr indent="0" marL="0">
+            <a:pPr marL="0" indent="0">
               <a:buNone/>
             </a:pPr>
             <a:r>
@@ -4534,7 +4438,7 @@
             <a:endParaRPr lang="en-US" sz="1500" dirty="0"/>
           </a:p>
           <a:p>
-            <a:pPr indent="0" marL="0">
+            <a:pPr marL="0" indent="0">
               <a:buNone/>
             </a:pPr>
             <a:r>
@@ -4548,7 +4452,7 @@
             <a:endParaRPr lang="en-US" sz="1500" dirty="0"/>
           </a:p>
           <a:p>
-            <a:pPr indent="0" marL="0">
+            <a:pPr marL="0" indent="0">
               <a:buNone/>
             </a:pPr>
             <a:r>
@@ -4584,7 +4488,7 @@
           <a:bodyPr wrap="square" rtlCol="0" anchor="ctr"/>
           <a:lstStyle/>
           <a:p>
-            <a:pPr algn="ctr" indent="0" marL="0">
+            <a:pPr marL="0" indent="0" algn="ctr">
               <a:buNone/>
             </a:pPr>
             <a:r>
@@ -4620,7 +4524,7 @@
           <a:bodyPr wrap="square" lIns="0" tIns="0" rIns="0" bIns="0" rtlCol="0" anchor="ctr"/>
           <a:lstStyle/>
           <a:p>
-            <a:pPr algn="r" indent="0" marL="0">
+            <a:pPr marL="0" indent="0" algn="r">
               <a:buNone/>
             </a:pPr>
             <a:r>
@@ -4936,4 +4840,319 @@
     </a:ext>
   </a:extLst>
 </a:theme>
+</file>
+
+<file path=ppt/theme/theme2.xml><?xml version="1.0" encoding="utf-8"?>
+<a:theme xmlns:a="http://schemas.openxmlformats.org/drawingml/2006/main" name="Office Theme">
+  <a:themeElements>
+    <a:clrScheme name="Office">
+      <a:dk1>
+        <a:sysClr val="windowText" lastClr="000000"/>
+      </a:dk1>
+      <a:lt1>
+        <a:sysClr val="window" lastClr="FFFFFF"/>
+      </a:lt1>
+      <a:dk2>
+        <a:srgbClr val="0E2841"/>
+      </a:dk2>
+      <a:lt2>
+        <a:srgbClr val="E8E8E8"/>
+      </a:lt2>
+      <a:accent1>
+        <a:srgbClr val="156082"/>
+      </a:accent1>
+      <a:accent2>
+        <a:srgbClr val="E97132"/>
+      </a:accent2>
+      <a:accent3>
+        <a:srgbClr val="196B24"/>
+      </a:accent3>
+      <a:accent4>
+        <a:srgbClr val="0F9ED5"/>
+      </a:accent4>
+      <a:accent5>
+        <a:srgbClr val="A02B93"/>
+      </a:accent5>
+      <a:accent6>
+        <a:srgbClr val="4EA72E"/>
+      </a:accent6>
+      <a:hlink>
+        <a:srgbClr val="467886"/>
+      </a:hlink>
+      <a:folHlink>
+        <a:srgbClr val="96607D"/>
+      </a:folHlink>
+    </a:clrScheme>
+    <a:fontScheme name="Office">
+      <a:majorFont>
+        <a:latin typeface="Aptos Display" panose="02110004020202020204"/>
+        <a:ea typeface=""/>
+        <a:cs typeface=""/>
+        <a:font script="Jpan" typeface="游ゴシック Light"/>
+        <a:font script="Hang" typeface="맑은 고딕"/>
+        <a:font script="Hans" typeface="等线 Light"/>
+        <a:font script="Hant" typeface="新細明體"/>
+        <a:font script="Arab" typeface="Times New Roman"/>
+        <a:font script="Hebr" typeface="Times New Roman"/>
+        <a:font script="Thai" typeface="Angsana New"/>
+        <a:font script="Ethi" typeface="Nyala"/>
+        <a:font script="Beng" typeface="Vrinda"/>
+        <a:font script="Gujr" typeface="Shruti"/>
+        <a:font script="Khmr" typeface="MoolBoran"/>
+        <a:font script="Knda" typeface="Tunga"/>
+        <a:font script="Guru" typeface="Raavi"/>
+        <a:font script="Cans" typeface="Euphemia"/>
+        <a:font script="Cher" typeface="Plantagenet Cherokee"/>
+        <a:font script="Yiii" typeface="Microsoft Yi Baiti"/>
+        <a:font script="Tibt" typeface="Microsoft Himalaya"/>
+        <a:font script="Thaa" typeface="MV Boli"/>
+        <a:font script="Deva" typeface="Mangal"/>
+        <a:font script="Telu" typeface="Gautami"/>
+        <a:font script="Taml" typeface="Latha"/>
+        <a:font script="Syrc" typeface="Estrangelo Edessa"/>
+        <a:font script="Orya" typeface="Kalinga"/>
+        <a:font script="Mlym" typeface="Kartika"/>
+        <a:font script="Laoo" typeface="DokChampa"/>
+        <a:font script="Sinh" typeface="Iskoola Pota"/>
+        <a:font script="Mong" typeface="Mongolian Baiti"/>
+        <a:font script="Viet" typeface="Times New Roman"/>
+        <a:font script="Uigh" typeface="Microsoft Uighur"/>
+        <a:font script="Geor" typeface="Sylfaen"/>
+        <a:font script="Armn" typeface="Arial"/>
+        <a:font script="Bugi" typeface="Leelawadee UI"/>
+        <a:font script="Bopo" typeface="Microsoft JhengHei"/>
+        <a:font script="Java" typeface="Javanese Text"/>
+        <a:font script="Lisu" typeface="Segoe UI"/>
+        <a:font script="Mymr" typeface="Myanmar Text"/>
+        <a:font script="Nkoo" typeface="Ebrima"/>
+        <a:font script="Olck" typeface="Nirmala UI"/>
+        <a:font script="Osma" typeface="Ebrima"/>
+        <a:font script="Phag" typeface="Phagspa"/>
+        <a:font script="Syrn" typeface="Estrangelo Edessa"/>
+        <a:font script="Syrj" typeface="Estrangelo Edessa"/>
+        <a:font script="Syre" typeface="Estrangelo Edessa"/>
+        <a:font script="Sora" typeface="Nirmala UI"/>
+        <a:font script="Tale" typeface="Microsoft Tai Le"/>
+        <a:font script="Talu" typeface="Microsoft New Tai Lue"/>
+        <a:font script="Tfng" typeface="Ebrima"/>
+      </a:majorFont>
+      <a:minorFont>
+        <a:latin typeface="Aptos" panose="02110004020202020204"/>
+        <a:ea typeface=""/>
+        <a:cs typeface=""/>
+        <a:font script="Jpan" typeface="游ゴシック"/>
+        <a:font script="Hang" typeface="맑은 고딕"/>
+        <a:font script="Hans" typeface="等线"/>
+        <a:font script="Hant" typeface="新細明體"/>
+        <a:font script="Arab" typeface="Arial"/>
+        <a:font script="Hebr" typeface="Arial"/>
+        <a:font script="Thai" typeface="Cordia New"/>
+        <a:font script="Ethi" typeface="Nyala"/>
+        <a:font script="Beng" typeface="Vrinda"/>
+        <a:font script="Gujr" typeface="Shruti"/>
+        <a:font script="Khmr" typeface="DaunPenh"/>
+        <a:font script="Knda" typeface="Tunga"/>
+        <a:font script="Guru" typeface="Raavi"/>
+        <a:font script="Cans" typeface="Euphemia"/>
+        <a:font script="Cher" typeface="Plantagenet Cherokee"/>
+        <a:font script="Yiii" typeface="Microsoft Yi Baiti"/>
+        <a:font script="Tibt" typeface="Microsoft Himalaya"/>
+        <a:font script="Thaa" typeface="MV Boli"/>
+        <a:font script="Deva" typeface="Mangal"/>
+        <a:font script="Telu" typeface="Gautami"/>
+        <a:font script="Taml" typeface="Latha"/>
+        <a:font script="Syrc" typeface="Estrangelo Edessa"/>
+        <a:font script="Orya" typeface="Kalinga"/>
+        <a:font script="Mlym" typeface="Kartika"/>
+        <a:font script="Laoo" typeface="DokChampa"/>
+        <a:font script="Sinh" typeface="Iskoola Pota"/>
+        <a:font script="Mong" typeface="Mongolian Baiti"/>
+        <a:font script="Viet" typeface="Arial"/>
+        <a:font script="Uigh" typeface="Microsoft Uighur"/>
+        <a:font script="Geor" typeface="Sylfaen"/>
+        <a:font script="Armn" typeface="Arial"/>
+        <a:font script="Bugi" typeface="Leelawadee UI"/>
+        <a:font script="Bopo" typeface="Microsoft JhengHei"/>
+        <a:font script="Java" typeface="Javanese Text"/>
+        <a:font script="Lisu" typeface="Segoe UI"/>
+        <a:font script="Mymr" typeface="Myanmar Text"/>
+        <a:font script="Nkoo" typeface="Ebrima"/>
+        <a:font script="Olck" typeface="Nirmala UI"/>
+        <a:font script="Osma" typeface="Ebrima"/>
+        <a:font script="Phag" typeface="Phagspa"/>
+        <a:font script="Syrn" typeface="Estrangelo Edessa"/>
+        <a:font script="Syrj" typeface="Estrangelo Edessa"/>
+        <a:font script="Syre" typeface="Estrangelo Edessa"/>
+        <a:font script="Sora" typeface="Nirmala UI"/>
+        <a:font script="Tale" typeface="Microsoft Tai Le"/>
+        <a:font script="Talu" typeface="Microsoft New Tai Lue"/>
+        <a:font script="Tfng" typeface="Ebrima"/>
+      </a:minorFont>
+    </a:fontScheme>
+    <a:fmtScheme name="Office">
+      <a:fillStyleLst>
+        <a:solidFill>
+          <a:schemeClr val="phClr"/>
+        </a:solidFill>
+        <a:gradFill rotWithShape="1">
+          <a:gsLst>
+            <a:gs pos="0">
+              <a:schemeClr val="phClr">
+                <a:lumMod val="110000"/>
+                <a:satMod val="105000"/>
+                <a:tint val="67000"/>
+              </a:schemeClr>
+            </a:gs>
+            <a:gs pos="50000">
+              <a:schemeClr val="phClr">
+                <a:lumMod val="105000"/>
+                <a:satMod val="103000"/>
+                <a:tint val="73000"/>
+              </a:schemeClr>
+            </a:gs>
+            <a:gs pos="100000">
+              <a:schemeClr val="phClr">
+                <a:lumMod val="105000"/>
+                <a:satMod val="109000"/>
+                <a:tint val="81000"/>
+              </a:schemeClr>
+            </a:gs>
+          </a:gsLst>
+          <a:lin ang="5400000" scaled="0"/>
+        </a:gradFill>
+        <a:gradFill rotWithShape="1">
+          <a:gsLst>
+            <a:gs pos="0">
+              <a:schemeClr val="phClr">
+                <a:satMod val="103000"/>
+                <a:lumMod val="102000"/>
+                <a:tint val="94000"/>
+              </a:schemeClr>
+            </a:gs>
+            <a:gs pos="50000">
+              <a:schemeClr val="phClr">
+                <a:satMod val="110000"/>
+                <a:lumMod val="100000"/>
+                <a:shade val="100000"/>
+              </a:schemeClr>
+            </a:gs>
+            <a:gs pos="100000">
+              <a:schemeClr val="phClr">
+                <a:lumMod val="99000"/>
+                <a:satMod val="120000"/>
+                <a:shade val="78000"/>
+              </a:schemeClr>
+            </a:gs>
+          </a:gsLst>
+          <a:lin ang="5400000" scaled="0"/>
+        </a:gradFill>
+      </a:fillStyleLst>
+      <a:lnStyleLst>
+        <a:ln w="12700" cap="flat" cmpd="sng" algn="ctr">
+          <a:solidFill>
+            <a:schemeClr val="phClr"/>
+          </a:solidFill>
+          <a:prstDash val="solid"/>
+          <a:miter lim="800000"/>
+        </a:ln>
+        <a:ln w="19050" cap="flat" cmpd="sng" algn="ctr">
+          <a:solidFill>
+            <a:schemeClr val="phClr"/>
+          </a:solidFill>
+          <a:prstDash val="solid"/>
+          <a:miter lim="800000"/>
+        </a:ln>
+        <a:ln w="25400" cap="flat" cmpd="sng" algn="ctr">
+          <a:solidFill>
+            <a:schemeClr val="phClr"/>
+          </a:solidFill>
+          <a:prstDash val="solid"/>
+          <a:miter lim="800000"/>
+        </a:ln>
+      </a:lnStyleLst>
+      <a:effectStyleLst>
+        <a:effectStyle>
+          <a:effectLst/>
+        </a:effectStyle>
+        <a:effectStyle>
+          <a:effectLst/>
+        </a:effectStyle>
+        <a:effectStyle>
+          <a:effectLst>
+            <a:outerShdw blurRad="57150" dist="19050" dir="5400000" algn="ctr" rotWithShape="0">
+              <a:srgbClr val="000000">
+                <a:alpha val="63000"/>
+              </a:srgbClr>
+            </a:outerShdw>
+          </a:effectLst>
+        </a:effectStyle>
+      </a:effectStyleLst>
+      <a:bgFillStyleLst>
+        <a:solidFill>
+          <a:schemeClr val="phClr"/>
+        </a:solidFill>
+        <a:solidFill>
+          <a:schemeClr val="phClr">
+            <a:tint val="95000"/>
+            <a:satMod val="170000"/>
+          </a:schemeClr>
+        </a:solidFill>
+        <a:gradFill rotWithShape="1">
+          <a:gsLst>
+            <a:gs pos="0">
+              <a:schemeClr val="phClr">
+                <a:tint val="93000"/>
+                <a:satMod val="150000"/>
+                <a:shade val="98000"/>
+                <a:lumMod val="102000"/>
+              </a:schemeClr>
+            </a:gs>
+            <a:gs pos="50000">
+              <a:schemeClr val="phClr">
+                <a:tint val="98000"/>
+                <a:satMod val="130000"/>
+                <a:shade val="90000"/>
+                <a:lumMod val="103000"/>
+              </a:schemeClr>
+            </a:gs>
+            <a:gs pos="100000">
+              <a:schemeClr val="phClr">
+                <a:shade val="63000"/>
+                <a:satMod val="120000"/>
+              </a:schemeClr>
+            </a:gs>
+          </a:gsLst>
+          <a:lin ang="5400000" scaled="0"/>
+        </a:gradFill>
+      </a:bgFillStyleLst>
+    </a:fmtScheme>
+  </a:themeElements>
+  <a:objectDefaults>
+    <a:lnDef>
+      <a:spPr/>
+      <a:bodyPr/>
+      <a:lstStyle/>
+      <a:style>
+        <a:lnRef idx="2">
+          <a:schemeClr val="accent1"/>
+        </a:lnRef>
+        <a:fillRef idx="0">
+          <a:schemeClr val="accent1"/>
+        </a:fillRef>
+        <a:effectRef idx="1">
+          <a:schemeClr val="accent1"/>
+        </a:effectRef>
+        <a:fontRef idx="minor">
+          <a:schemeClr val="tx1"/>
+        </a:fontRef>
+      </a:style>
+    </a:lnDef>
+  </a:objectDefaults>
+  <a:extraClrSchemeLst/>
+  <a:extLst>
+    <a:ext uri="{05A4C25C-085E-4340-85A3-A5531E510DB2}">
+      <thm15:themeFamily xmlns:thm15="http://schemas.microsoft.com/office/thememl/2012/main" name="Office Theme" id="{2E142A2C-CD16-42D6-873A-C26D2A0506FA}" vid="{1BDDFF52-6CD6-40A5-AB3C-68EB2F1E4D0A}"/>
+    </a:ext>
+  </a:extLst>
+</a:theme>
 </file>
</xml_diff>